<commit_message>
docs: add live app link to ppt presentation slides
</commit_message>
<xml_diff>
--- a/Submission/EduTrack_Presentation_Fixed.pptx
+++ b/Submission/EduTrack_Presentation_Fixed.pptx
@@ -13,9 +13,10 @@
     <p:sldId id="261" r:id="rId7"/>
     <p:sldId id="262" r:id="rId8"/>
     <p:sldId id="263" r:id="rId9"/>
+    <p:sldId id="264" r:id="rId10"/>
   </p:sldIdLst>
   <p:notesMasterIdLst>
-    <p:notesMasterId r:id="rId10"/>
+    <p:notesMasterId r:id="rId11"/>
   </p:notesMasterIdLst>
   <p:sldSz cx="12192000" cy="6858000"/>
   <p:notesSz cx="6858000" cy="12192000"/>
@@ -1149,6 +1150,94 @@
             <a:fld id="{F7021451-1387-4CA6-816F-3879F97B5CBC}" type="slidenum">
               <a:rPr lang="en-US"/>
               <a:t>8</a:t>
+            </a:fld>
+            <a:endParaRPr lang="en-US"/>
+          </a:p>
+        </p:txBody>
+      </p:sp>
+    </p:spTree>
+    <p:extLst>
+      <p:ext uri="{BB962C8B-B14F-4D97-AF65-F5344CB8AC3E}">
+        <p14:creationId xmlns:p14="http://schemas.microsoft.com/office/powerpoint/2010/main" val="1024086991"/>
+      </p:ext>
+    </p:extLst>
+  </p:cSld>
+  <p:clrMapOvr>
+    <a:masterClrMapping/>
+  </p:clrMapOvr>
+</p:notes>
+</file>
+
+<file path=ppt/notesSlides/notesSlide9.xml><?xml version="1.0" encoding="utf-8"?>
+<p:notes xmlns:a="http://schemas.openxmlformats.org/drawingml/2006/main" xmlns:r="http://schemas.openxmlformats.org/officeDocument/2006/relationships" xmlns:p="http://schemas.openxmlformats.org/presentationml/2006/main">
+  <p:cSld>
+    <p:spTree>
+      <p:nvGrpSpPr>
+        <p:cNvPr id="1" name=""/>
+        <p:cNvGrpSpPr/>
+        <p:nvPr/>
+      </p:nvGrpSpPr>
+      <p:grpSpPr>
+        <a:xfrm>
+          <a:off x="0" y="0"/>
+          <a:ext cx="0" cy="0"/>
+          <a:chOff x="0" y="0"/>
+          <a:chExt cx="0" cy="0"/>
+        </a:xfrm>
+      </p:grpSpPr>
+      <p:sp>
+        <p:nvSpPr>
+          <p:cNvPr id="2" name="Slide Image Placeholder 1"/>
+          <p:cNvSpPr>
+            <a:spLocks noGrp="1" noRot="1" noChangeAspect="1"/>
+          </p:cNvSpPr>
+          <p:nvPr>
+            <p:ph type="sldImg"/>
+          </p:nvPr>
+        </p:nvSpPr>
+        <p:spPr/>
+      </p:sp>
+      <p:sp>
+        <p:nvSpPr>
+          <p:cNvPr id="3" name="Notes Placeholder 2"/>
+          <p:cNvSpPr>
+            <a:spLocks noGrp="1"/>
+          </p:cNvSpPr>
+          <p:nvPr>
+            <p:ph type="body" idx="1"/>
+          </p:nvPr>
+        </p:nvSpPr>
+        <p:spPr/>
+        <p:txBody>
+          <a:bodyPr/>
+          <a:lstStyle/>
+          <a:p>
+            <a:r>
+              <a:rPr lang="en-US" dirty="0"/>
+              <a:t/>
+            </a:r>
+            <a:endParaRPr lang="en-US" dirty="0"/>
+          </a:p>
+        </p:txBody>
+      </p:sp>
+      <p:sp>
+        <p:nvSpPr>
+          <p:cNvPr id="4" name="Slide Number Placeholder 3"/>
+          <p:cNvSpPr>
+            <a:spLocks noGrp="1"/>
+          </p:cNvSpPr>
+          <p:nvPr>
+            <p:ph type="sldNum" sz="quarter" idx="10"/>
+          </p:nvPr>
+        </p:nvSpPr>
+        <p:spPr/>
+        <p:txBody>
+          <a:bodyPr/>
+          <a:lstStyle/>
+          <a:p>
+            <a:fld id="{F7021451-1387-4CA6-816F-3879F97B5CBC}" type="slidenum">
+              <a:rPr lang="en-US"/>
+              <a:t>9</a:t>
             </a:fld>
             <a:endParaRPr lang="en-US"/>
           </a:p>
@@ -1622,7 +1711,7 @@
         </p:nvSpPr>
         <p:spPr>
           <a:xfrm>
-            <a:off x="731520" y="3474720"/>
+            <a:off x="731520" y="3383280"/>
             <a:ext cx="2926080" cy="365760"/>
           </a:xfrm>
           <a:prstGeom prst="rect">
@@ -1661,7 +1750,7 @@
         </p:nvSpPr>
         <p:spPr>
           <a:xfrm>
-            <a:off x="3657600" y="3474720"/>
+            <a:off x="3657600" y="3383280"/>
             <a:ext cx="7315200" cy="365760"/>
           </a:xfrm>
           <a:prstGeom prst="rect">
@@ -1700,7 +1789,7 @@
         </p:nvSpPr>
         <p:spPr>
           <a:xfrm>
-            <a:off x="731520" y="3886200"/>
+            <a:off x="731520" y="3794760"/>
             <a:ext cx="2926080" cy="365760"/>
           </a:xfrm>
           <a:prstGeom prst="rect">
@@ -1739,7 +1828,7 @@
         </p:nvSpPr>
         <p:spPr>
           <a:xfrm>
-            <a:off x="3657600" y="3886200"/>
+            <a:off x="3657600" y="3794760"/>
             <a:ext cx="7315200" cy="365760"/>
           </a:xfrm>
           <a:prstGeom prst="rect">
@@ -1778,7 +1867,7 @@
         </p:nvSpPr>
         <p:spPr>
           <a:xfrm>
-            <a:off x="731520" y="4297680"/>
+            <a:off x="731520" y="4206240"/>
             <a:ext cx="2926080" cy="365760"/>
           </a:xfrm>
           <a:prstGeom prst="rect">
@@ -1817,7 +1906,7 @@
         </p:nvSpPr>
         <p:spPr>
           <a:xfrm>
-            <a:off x="3657600" y="4297680"/>
+            <a:off x="3657600" y="4206240"/>
             <a:ext cx="7315200" cy="365760"/>
           </a:xfrm>
           <a:prstGeom prst="rect">
@@ -1856,7 +1945,7 @@
         </p:nvSpPr>
         <p:spPr>
           <a:xfrm>
-            <a:off x="731520" y="4709160"/>
+            <a:off x="731520" y="4617720"/>
             <a:ext cx="2926080" cy="365760"/>
           </a:xfrm>
           <a:prstGeom prst="rect">
@@ -1895,7 +1984,7 @@
         </p:nvSpPr>
         <p:spPr>
           <a:xfrm>
-            <a:off x="3657600" y="4709160"/>
+            <a:off x="3657600" y="4617720"/>
             <a:ext cx="7315200" cy="365760"/>
           </a:xfrm>
           <a:prstGeom prst="rect">
@@ -1934,7 +2023,7 @@
         </p:nvSpPr>
         <p:spPr>
           <a:xfrm>
-            <a:off x="731520" y="5120640"/>
+            <a:off x="731520" y="5029200"/>
             <a:ext cx="2926080" cy="365760"/>
           </a:xfrm>
           <a:prstGeom prst="rect">
@@ -1973,7 +2062,7 @@
         </p:nvSpPr>
         <p:spPr>
           <a:xfrm>
-            <a:off x="3657600" y="5120640"/>
+            <a:off x="3657600" y="5029200"/>
             <a:ext cx="7315200" cy="365760"/>
           </a:xfrm>
           <a:prstGeom prst="rect">
@@ -1999,6 +2088,93 @@
                 <a:cs typeface="Arial" pitchFamily="34" charset="-120"/>
               </a:rPr>
               <a:t>Bal Bharati Public School, Navi Mumbai</a:t>
+            </a:r>
+            <a:endParaRPr lang="en-US" sz="1600" dirty="0"/>
+          </a:p>
+        </p:txBody>
+      </p:sp>
+      <p:sp>
+        <p:nvSpPr>
+          <p:cNvPr id="16" name="Text 14"/>
+          <p:cNvSpPr/>
+          <p:nvPr/>
+        </p:nvSpPr>
+        <p:spPr>
+          <a:xfrm>
+            <a:off x="731520" y="5440680"/>
+            <a:ext cx="2926080" cy="365760"/>
+          </a:xfrm>
+          <a:prstGeom prst="rect">
+            <a:avLst/>
+          </a:prstGeom>
+          <a:noFill/>
+          <a:ln/>
+        </p:spPr>
+        <p:txBody>
+          <a:bodyPr wrap="square" rtlCol="0" anchor="ctr"/>
+          <a:lstStyle/>
+          <a:p>
+            <a:pPr indent="0" marL="0">
+              <a:buNone/>
+            </a:pPr>
+            <a:r>
+              <a:rPr lang="en-US" sz="1600" b="1" dirty="0">
+                <a:solidFill>
+                  <a:srgbClr val="6366F1"/>
+                </a:solidFill>
+                <a:latin typeface="Arial" pitchFamily="34" charset="0"/>
+                <a:ea typeface="Arial" pitchFamily="34" charset="-122"/>
+                <a:cs typeface="Arial" pitchFamily="34" charset="-120"/>
+              </a:rPr>
+              <a:t>Application Link : </a:t>
+            </a:r>
+            <a:endParaRPr lang="en-US" sz="1600" dirty="0"/>
+          </a:p>
+        </p:txBody>
+      </p:sp>
+      <p:sp>
+        <p:nvSpPr>
+          <p:cNvPr id="17" name="Text 15">
+            <a:hlinkClick r:id="rId1" tooltip=""/>
+          </p:cNvPr>
+          <p:cNvSpPr/>
+          <p:nvPr/>
+        </p:nvSpPr>
+        <p:spPr>
+          <a:xfrm>
+            <a:off x="3657600" y="5440680"/>
+            <a:ext cx="7315200" cy="365760"/>
+          </a:xfrm>
+          <a:prstGeom prst="rect">
+            <a:avLst/>
+          </a:prstGeom>
+          <a:noFill/>
+          <a:ln/>
+        </p:spPr>
+        <p:txBody>
+          <a:bodyPr wrap="square" rtlCol="0" anchor="ctr"/>
+          <a:lstStyle/>
+          <a:p>
+            <a:pPr indent="0" marL="0">
+              <a:buNone/>
+            </a:pPr>
+            <a:r>
+              <a:rPr lang="en-US" sz="1600" b="1" u="sng" dirty="0">
+                <a:solidFill>
+                  <a:srgbClr val="6366F1"/>
+                </a:solidFill>
+                <a:latin typeface="Arial" pitchFamily="34" charset="0"/>
+                <a:ea typeface="Arial" pitchFamily="34" charset="-122"/>
+                <a:cs typeface="Arial" pitchFamily="34" charset="-120"/>
+                <a:hlinkClick r:id="rId1" invalidUrl="" action="" tgtFrame="" tooltip="" history="1" highlightClick="0" endSnd="0">
+                  <a:extLst>
+                    <a:ext uri="{A12FA001-AC4F-418D-AE19-62706E023703}">
+                      <ahyp:hlinkClr xmlns:ahyp="http://schemas.microsoft.com/office/drawing/2018/hyperlinkcolor" val="tx"/>
+                    </a:ext>
+                  </a:extLst>
+                </a:hlinkClick>
+              </a:rPr>
+              <a:t>https://edutrack.app</a:t>
             </a:r>
             <a:endParaRPr lang="en-US" sz="1600" dirty="0"/>
           </a:p>
@@ -7412,7 +7588,7 @@
         </p:nvSpPr>
         <p:spPr>
           <a:xfrm>
-            <a:off x="2286000" y="5120640"/>
+            <a:off x="2286000" y="5029200"/>
             <a:ext cx="7616952" cy="457200"/>
           </a:xfrm>
           <a:prstGeom prst="rect">
@@ -7427,12 +7603,12 @@
           <a:p>
             <a:pPr algn="ctr" indent="0" marL="0">
               <a:lnSpc>
-                <a:spcPts val="1600"/>
-              </a:lnSpc>
-              <a:buNone/>
-            </a:pPr>
-            <a:r>
-              <a:rPr lang="en-US" sz="1200" dirty="0">
+                <a:spcPts val="1400"/>
+              </a:lnSpc>
+              <a:buNone/>
+            </a:pPr>
+            <a:r>
+              <a:rPr lang="en-US" sz="1100" dirty="0">
                 <a:solidFill>
                   <a:srgbClr val="94A3B8"/>
                 </a:solidFill>
@@ -7442,17 +7618,17 @@
               </a:rPr>
               <a:t>Interactive Walkthrough Highlights:</a:t>
             </a:r>
-            <a:endParaRPr lang="en-US" sz="1200" dirty="0"/>
+            <a:endParaRPr lang="en-US" sz="1100" dirty="0"/>
           </a:p>
           <a:p>
             <a:pPr algn="ctr" indent="0" marL="0">
               <a:lnSpc>
-                <a:spcPts val="1600"/>
-              </a:lnSpc>
-              <a:buNone/>
-            </a:pPr>
-            <a:r>
-              <a:rPr lang="en-US" sz="1200" dirty="0">
+                <a:spcPts val="1400"/>
+              </a:lnSpc>
+              <a:buNone/>
+            </a:pPr>
+            <a:r>
+              <a:rPr lang="en-US" sz="1100" dirty="0">
                 <a:solidFill>
                   <a:srgbClr val="94A3B8"/>
                 </a:solidFill>
@@ -7462,7 +7638,55 @@
               </a:rPr>
               <a:t>Dashboard Navigation • Dynamic AI Textbook Hinglish Explanations • Leitner Box Recalls • Peer Chat</a:t>
             </a:r>
-            <a:endParaRPr lang="en-US" sz="1200" dirty="0"/>
+            <a:endParaRPr lang="en-US" sz="1100" dirty="0"/>
+          </a:p>
+        </p:txBody>
+      </p:sp>
+      <p:sp>
+        <p:nvSpPr>
+          <p:cNvPr id="10" name="Text 8">
+            <a:hlinkClick r:id="rId1" tooltip=""/>
+          </p:cNvPr>
+          <p:cNvSpPr/>
+          <p:nvPr/>
+        </p:nvSpPr>
+        <p:spPr>
+          <a:xfrm>
+            <a:off x="2286000" y="5486400"/>
+            <a:ext cx="7616952" cy="320040"/>
+          </a:xfrm>
+          <a:prstGeom prst="rect">
+            <a:avLst/>
+          </a:prstGeom>
+          <a:noFill/>
+          <a:ln/>
+        </p:spPr>
+        <p:txBody>
+          <a:bodyPr wrap="square" rtlCol="0" anchor="ctr"/>
+          <a:lstStyle/>
+          <a:p>
+            <a:pPr algn="ctr" indent="0" marL="0">
+              <a:buNone/>
+            </a:pPr>
+            <a:r>
+              <a:rPr lang="en-US" sz="1400" b="1" u="sng" dirty="0">
+                <a:solidFill>
+                  <a:srgbClr val="10B981"/>
+                </a:solidFill>
+                <a:latin typeface="Arial" pitchFamily="34" charset="0"/>
+                <a:ea typeface="Arial" pitchFamily="34" charset="-122"/>
+                <a:cs typeface="Arial" pitchFamily="34" charset="-120"/>
+                <a:hlinkClick r:id="rId1" invalidUrl="" action="" tgtFrame="" tooltip="" history="1" highlightClick="0" endSnd="0">
+                  <a:extLst>
+                    <a:ext uri="{A12FA001-AC4F-418D-AE19-62706E023703}">
+                      <ahyp:hlinkClr xmlns:ahyp="http://schemas.microsoft.com/office/drawing/2018/hyperlinkcolor" val="tx"/>
+                    </a:ext>
+                  </a:extLst>
+                </a:hlinkClick>
+              </a:rPr>
+              <a:t>Access Live Application: https://edutrack.app</a:t>
+            </a:r>
+            <a:endParaRPr lang="en-US" sz="1400" dirty="0"/>
           </a:p>
         </p:txBody>
       </p:sp>
@@ -8252,6 +8476,579 @@
               <a:t>• Modular Hook wrapper: Easily callable in NCERT textbooks (+50 XP), flashcard spaced review box promotions (+15 XP), or PYQ assessments.</a:t>
             </a:r>
             <a:endParaRPr lang="en-US" sz="1150" dirty="0"/>
+          </a:p>
+        </p:txBody>
+      </p:sp>
+    </p:spTree>
+  </p:cSld>
+  <p:clrMapOvr>
+    <a:masterClrMapping/>
+  </p:clrMapOvr>
+</p:sld>
+</file>
+
+<file path=ppt/slides/slide9.xml><?xml version="1.0" encoding="utf-8"?>
+<p:sld xmlns:a="http://schemas.openxmlformats.org/drawingml/2006/main" xmlns:r="http://schemas.openxmlformats.org/officeDocument/2006/relationships" xmlns:p="http://schemas.openxmlformats.org/presentationml/2006/main">
+  <p:cSld name="Slide 9">
+    <p:bg>
+      <p:bgPr>
+        <a:solidFill>
+          <a:srgbClr val="03050C"/>
+        </a:solidFill>
+      </p:bgPr>
+    </p:bg>
+    <p:spTree>
+      <p:nvGrpSpPr>
+        <p:cNvPr id="1" name=""/>
+        <p:cNvGrpSpPr/>
+        <p:nvPr/>
+      </p:nvGrpSpPr>
+      <p:grpSpPr>
+        <a:xfrm>
+          <a:off x="0" y="0"/>
+          <a:ext cx="0" cy="0"/>
+          <a:chOff x="0" y="0"/>
+          <a:chExt cx="0" cy="0"/>
+        </a:xfrm>
+      </p:grpSpPr>
+      <p:sp>
+        <p:nvSpPr>
+          <p:cNvPr id="2" name="Text 0"/>
+          <p:cNvSpPr/>
+          <p:nvPr/>
+        </p:nvSpPr>
+        <p:spPr>
+          <a:xfrm>
+            <a:off x="457200" y="365760"/>
+            <a:ext cx="8229600" cy="548640"/>
+          </a:xfrm>
+          <a:prstGeom prst="rect">
+            <a:avLst/>
+          </a:prstGeom>
+          <a:noFill/>
+          <a:ln/>
+        </p:spPr>
+        <p:txBody>
+          <a:bodyPr wrap="square" rtlCol="0" anchor="ctr"/>
+          <a:lstStyle/>
+          <a:p>
+            <a:pPr indent="0" marL="0">
+              <a:buNone/>
+            </a:pPr>
+            <a:r>
+              <a:rPr lang="en-US" sz="2800" b="1" dirty="0">
+                <a:solidFill>
+                  <a:srgbClr val="FFFFFF"/>
+                </a:solidFill>
+                <a:latin typeface="Arial" pitchFamily="34" charset="0"/>
+                <a:ea typeface="Arial" pitchFamily="34" charset="-122"/>
+                <a:cs typeface="Arial" pitchFamily="34" charset="-120"/>
+              </a:rPr>
+              <a:t>Project Access &amp; Codebase</a:t>
+            </a:r>
+            <a:endParaRPr lang="en-US" sz="2800" dirty="0"/>
+          </a:p>
+        </p:txBody>
+      </p:sp>
+      <p:sp>
+        <p:nvSpPr>
+          <p:cNvPr id="3" name="Shape 1"/>
+          <p:cNvSpPr/>
+          <p:nvPr/>
+        </p:nvSpPr>
+        <p:spPr>
+          <a:xfrm>
+            <a:off x="457200" y="1005840"/>
+            <a:ext cx="11274552" cy="18288"/>
+          </a:xfrm>
+          <a:prstGeom prst="rect">
+            <a:avLst/>
+          </a:prstGeom>
+          <a:solidFill>
+            <a:srgbClr val="6366F1"/>
+          </a:solidFill>
+          <a:ln/>
+        </p:spPr>
+      </p:sp>
+      <p:sp>
+        <p:nvSpPr>
+          <p:cNvPr id="4" name="Shape 2"/>
+          <p:cNvSpPr/>
+          <p:nvPr/>
+        </p:nvSpPr>
+        <p:spPr>
+          <a:xfrm>
+            <a:off x="457200" y="1371600"/>
+            <a:ext cx="5486400" cy="4754880"/>
+          </a:xfrm>
+          <a:prstGeom prst="roundRect">
+            <a:avLst/>
+          </a:prstGeom>
+          <a:solidFill>
+            <a:srgbClr val="0C0F1D"/>
+          </a:solidFill>
+          <a:ln w="19050">
+            <a:solidFill>
+              <a:srgbClr val="252B44"/>
+            </a:solidFill>
+            <a:prstDash val="solid"/>
+          </a:ln>
+        </p:spPr>
+      </p:sp>
+      <p:sp>
+        <p:nvSpPr>
+          <p:cNvPr id="5" name="Text 3"/>
+          <p:cNvSpPr/>
+          <p:nvPr/>
+        </p:nvSpPr>
+        <p:spPr>
+          <a:xfrm>
+            <a:off x="731520" y="1645920"/>
+            <a:ext cx="4937760" cy="365760"/>
+          </a:xfrm>
+          <a:prstGeom prst="rect">
+            <a:avLst/>
+          </a:prstGeom>
+          <a:noFill/>
+          <a:ln/>
+        </p:spPr>
+        <p:txBody>
+          <a:bodyPr wrap="square" rtlCol="0" anchor="ctr"/>
+          <a:lstStyle/>
+          <a:p>
+            <a:pPr indent="0" marL="0">
+              <a:buNone/>
+            </a:pPr>
+            <a:r>
+              <a:rPr lang="en-US" sz="2200" b="1" dirty="0">
+                <a:solidFill>
+                  <a:srgbClr val="10B981"/>
+                </a:solidFill>
+                <a:latin typeface="Arial" pitchFamily="34" charset="0"/>
+                <a:ea typeface="Arial" pitchFamily="34" charset="-122"/>
+                <a:cs typeface="Arial" pitchFamily="34" charset="-120"/>
+              </a:rPr>
+              <a:t>Live Deployed Platform</a:t>
+            </a:r>
+            <a:endParaRPr lang="en-US" sz="2200" dirty="0"/>
+          </a:p>
+        </p:txBody>
+      </p:sp>
+      <p:sp>
+        <p:nvSpPr>
+          <p:cNvPr id="6" name="Text 4">
+            <a:hlinkClick r:id="rId1" tooltip=""/>
+          </p:cNvPr>
+          <p:cNvSpPr/>
+          <p:nvPr/>
+        </p:nvSpPr>
+        <p:spPr>
+          <a:xfrm>
+            <a:off x="731520" y="2103120"/>
+            <a:ext cx="4937760" cy="457200"/>
+          </a:xfrm>
+          <a:prstGeom prst="rect">
+            <a:avLst/>
+          </a:prstGeom>
+          <a:noFill/>
+          <a:ln/>
+        </p:spPr>
+        <p:txBody>
+          <a:bodyPr wrap="square" rtlCol="0" anchor="ctr"/>
+          <a:lstStyle/>
+          <a:p>
+            <a:pPr indent="0" marL="0">
+              <a:buNone/>
+            </a:pPr>
+            <a:r>
+              <a:rPr lang="en-US" sz="2000" b="1" u="sng" dirty="0">
+                <a:solidFill>
+                  <a:srgbClr val="6366F1"/>
+                </a:solidFill>
+                <a:latin typeface="Arial" pitchFamily="34" charset="0"/>
+                <a:ea typeface="Arial" pitchFamily="34" charset="-122"/>
+                <a:cs typeface="Arial" pitchFamily="34" charset="-120"/>
+                <a:hlinkClick r:id="rId1" invalidUrl="" action="" tgtFrame="" tooltip="" history="1" highlightClick="0" endSnd="0">
+                  <a:extLst>
+                    <a:ext uri="{A12FA001-AC4F-418D-AE19-62706E023703}">
+                      <ahyp:hlinkClr xmlns:ahyp="http://schemas.microsoft.com/office/drawing/2018/hyperlinkcolor" val="tx"/>
+                    </a:ext>
+                  </a:extLst>
+                </a:hlinkClick>
+              </a:rPr>
+              <a:t>https://edutrack.app</a:t>
+            </a:r>
+            <a:endParaRPr lang="en-US" sz="2000" dirty="0"/>
+          </a:p>
+        </p:txBody>
+      </p:sp>
+      <p:sp>
+        <p:nvSpPr>
+          <p:cNvPr id="7" name="Text 5"/>
+          <p:cNvSpPr/>
+          <p:nvPr/>
+        </p:nvSpPr>
+        <p:spPr>
+          <a:xfrm>
+            <a:off x="731520" y="2743200"/>
+            <a:ext cx="4937760" cy="2926080"/>
+          </a:xfrm>
+          <a:prstGeom prst="rect">
+            <a:avLst/>
+          </a:prstGeom>
+          <a:noFill/>
+          <a:ln/>
+        </p:spPr>
+        <p:txBody>
+          <a:bodyPr wrap="square" rtlCol="0" anchor="ctr"/>
+          <a:lstStyle/>
+          <a:p>
+            <a:pPr indent="0" marL="0">
+              <a:lnSpc>
+                <a:spcPts val="1800"/>
+              </a:lnSpc>
+              <a:buNone/>
+            </a:pPr>
+            <a:r>
+              <a:rPr lang="en-US" sz="1250" dirty="0">
+                <a:solidFill>
+                  <a:srgbClr val="FFFFFF"/>
+                </a:solidFill>
+                <a:latin typeface="Arial" pitchFamily="34" charset="0"/>
+                <a:ea typeface="Arial" pitchFamily="34" charset="-122"/>
+                <a:cs typeface="Arial" pitchFamily="34" charset="-120"/>
+              </a:rPr>
+              <a:t>• Production URL: Deployed to cloud infrastructure for low-latency delivery.</a:t>
+            </a:r>
+            <a:endParaRPr lang="en-US" sz="1250" dirty="0"/>
+          </a:p>
+          <a:p>
+            <a:pPr indent="0" marL="0">
+              <a:lnSpc>
+                <a:spcPts val="1800"/>
+              </a:lnSpc>
+              <a:buNone/>
+            </a:pPr>
+            <a:endParaRPr lang="en-US" sz="1250" dirty="0"/>
+          </a:p>
+          <a:p>
+            <a:pPr indent="0" marL="0">
+              <a:lnSpc>
+                <a:spcPts val="1800"/>
+              </a:lnSpc>
+              <a:buNone/>
+            </a:pPr>
+            <a:r>
+              <a:rPr lang="en-US" sz="1250" dirty="0">
+                <a:solidFill>
+                  <a:srgbClr val="FFFFFF"/>
+                </a:solidFill>
+                <a:latin typeface="Arial" pitchFamily="34" charset="0"/>
+                <a:ea typeface="Arial" pitchFamily="34" charset="-122"/>
+                <a:cs typeface="Arial" pitchFamily="34" charset="-120"/>
+              </a:rPr>
+              <a:t>• Fully Responsive: Optimized for desktops, tablets, and smart boards in classrooms.</a:t>
+            </a:r>
+            <a:endParaRPr lang="en-US" sz="1250" dirty="0"/>
+          </a:p>
+          <a:p>
+            <a:pPr indent="0" marL="0">
+              <a:lnSpc>
+                <a:spcPts val="1800"/>
+              </a:lnSpc>
+              <a:buNone/>
+            </a:pPr>
+            <a:endParaRPr lang="en-US" sz="1250" dirty="0"/>
+          </a:p>
+          <a:p>
+            <a:pPr indent="0" marL="0">
+              <a:lnSpc>
+                <a:spcPts val="1800"/>
+              </a:lnSpc>
+              <a:buNone/>
+            </a:pPr>
+            <a:r>
+              <a:rPr lang="en-US" sz="1250" dirty="0">
+                <a:solidFill>
+                  <a:srgbClr val="FFFFFF"/>
+                </a:solidFill>
+                <a:latin typeface="Arial" pitchFamily="34" charset="0"/>
+                <a:ea typeface="Arial" pitchFamily="34" charset="-122"/>
+                <a:cs typeface="Arial" pitchFamily="34" charset="-120"/>
+              </a:rPr>
+              <a:t>• Firebase Integration: Handles secure real-time authentication and synchronized peer sessions seamlessly.</a:t>
+            </a:r>
+            <a:endParaRPr lang="en-US" sz="1250" dirty="0"/>
+          </a:p>
+          <a:p>
+            <a:pPr indent="0" marL="0">
+              <a:lnSpc>
+                <a:spcPts val="1800"/>
+              </a:lnSpc>
+              <a:buNone/>
+            </a:pPr>
+            <a:endParaRPr lang="en-US" sz="1250" dirty="0"/>
+          </a:p>
+          <a:p>
+            <a:pPr indent="0" marL="0">
+              <a:lnSpc>
+                <a:spcPts val="1800"/>
+              </a:lnSpc>
+              <a:buNone/>
+            </a:pPr>
+            <a:r>
+              <a:rPr lang="en-US" sz="1250" dirty="0">
+                <a:solidFill>
+                  <a:srgbClr val="FFFFFF"/>
+                </a:solidFill>
+                <a:latin typeface="Arial" pitchFamily="34" charset="0"/>
+                <a:ea typeface="Arial" pitchFamily="34" charset="-122"/>
+                <a:cs typeface="Arial" pitchFamily="34" charset="-120"/>
+              </a:rPr>
+              <a:t>• Ready to Test: Create a free account or login to explore AI tutors, homework lens scanner, Leitner cards, and collaborative whiteboard.</a:t>
+            </a:r>
+            <a:endParaRPr lang="en-US" sz="1250" dirty="0"/>
+          </a:p>
+        </p:txBody>
+      </p:sp>
+      <p:sp>
+        <p:nvSpPr>
+          <p:cNvPr id="8" name="Shape 6"/>
+          <p:cNvSpPr/>
+          <p:nvPr/>
+        </p:nvSpPr>
+        <p:spPr>
+          <a:xfrm>
+            <a:off x="6217920" y="1371600"/>
+            <a:ext cx="5486400" cy="4754880"/>
+          </a:xfrm>
+          <a:prstGeom prst="roundRect">
+            <a:avLst/>
+          </a:prstGeom>
+          <a:solidFill>
+            <a:srgbClr val="0C0F1D"/>
+          </a:solidFill>
+          <a:ln w="19050">
+            <a:solidFill>
+              <a:srgbClr val="252B44"/>
+            </a:solidFill>
+            <a:prstDash val="solid"/>
+          </a:ln>
+        </p:spPr>
+      </p:sp>
+      <p:sp>
+        <p:nvSpPr>
+          <p:cNvPr id="9" name="Text 7"/>
+          <p:cNvSpPr/>
+          <p:nvPr/>
+        </p:nvSpPr>
+        <p:spPr>
+          <a:xfrm>
+            <a:off x="6492240" y="1645920"/>
+            <a:ext cx="4937760" cy="365760"/>
+          </a:xfrm>
+          <a:prstGeom prst="rect">
+            <a:avLst/>
+          </a:prstGeom>
+          <a:noFill/>
+          <a:ln/>
+        </p:spPr>
+        <p:txBody>
+          <a:bodyPr wrap="square" rtlCol="0" anchor="ctr"/>
+          <a:lstStyle/>
+          <a:p>
+            <a:pPr indent="0" marL="0">
+              <a:buNone/>
+            </a:pPr>
+            <a:r>
+              <a:rPr lang="en-US" sz="2200" b="1" dirty="0">
+                <a:solidFill>
+                  <a:srgbClr val="F59E0B"/>
+                </a:solidFill>
+                <a:latin typeface="Arial" pitchFamily="34" charset="0"/>
+                <a:ea typeface="Arial" pitchFamily="34" charset="-122"/>
+                <a:cs typeface="Arial" pitchFamily="34" charset="-120"/>
+              </a:rPr>
+              <a:t>GitHub Repository</a:t>
+            </a:r>
+            <a:endParaRPr lang="en-US" sz="2200" dirty="0"/>
+          </a:p>
+        </p:txBody>
+      </p:sp>
+      <p:sp>
+        <p:nvSpPr>
+          <p:cNvPr id="10" name="Text 8">
+            <a:hlinkClick r:id="rId2" tooltip=""/>
+          </p:cNvPr>
+          <p:cNvSpPr/>
+          <p:nvPr/>
+        </p:nvSpPr>
+        <p:spPr>
+          <a:xfrm>
+            <a:off x="6492240" y="2103120"/>
+            <a:ext cx="4937760" cy="457200"/>
+          </a:xfrm>
+          <a:prstGeom prst="rect">
+            <a:avLst/>
+          </a:prstGeom>
+          <a:noFill/>
+          <a:ln/>
+        </p:spPr>
+        <p:txBody>
+          <a:bodyPr wrap="square" rtlCol="0" anchor="ctr"/>
+          <a:lstStyle/>
+          <a:p>
+            <a:pPr indent="0" marL="0">
+              <a:buNone/>
+            </a:pPr>
+            <a:r>
+              <a:rPr lang="en-US" sz="2000" b="1" u="sng" dirty="0">
+                <a:solidFill>
+                  <a:srgbClr val="6366F1"/>
+                </a:solidFill>
+                <a:latin typeface="Arial" pitchFamily="34" charset="0"/>
+                <a:ea typeface="Arial" pitchFamily="34" charset="-122"/>
+                <a:cs typeface="Arial" pitchFamily="34" charset="-120"/>
+                <a:hlinkClick r:id="rId2" invalidUrl="" action="" tgtFrame="" tooltip="" history="1" highlightClick="0" endSnd="0">
+                  <a:extLst>
+                    <a:ext uri="{A12FA001-AC4F-418D-AE19-62706E023703}">
+                      <ahyp:hlinkClr xmlns:ahyp="http://schemas.microsoft.com/office/drawing/2018/hyperlinkcolor" val="tx"/>
+                    </a:ext>
+                  </a:extLst>
+                </a:hlinkClick>
+              </a:rPr>
+              <a:t>GitHub Codebase Link</a:t>
+            </a:r>
+            <a:endParaRPr lang="en-US" sz="2000" dirty="0"/>
+          </a:p>
+        </p:txBody>
+      </p:sp>
+      <p:sp>
+        <p:nvSpPr>
+          <p:cNvPr id="11" name="Text 9"/>
+          <p:cNvSpPr/>
+          <p:nvPr/>
+        </p:nvSpPr>
+        <p:spPr>
+          <a:xfrm>
+            <a:off x="6492240" y="2743200"/>
+            <a:ext cx="4937760" cy="2926080"/>
+          </a:xfrm>
+          <a:prstGeom prst="rect">
+            <a:avLst/>
+          </a:prstGeom>
+          <a:noFill/>
+          <a:ln/>
+        </p:spPr>
+        <p:txBody>
+          <a:bodyPr wrap="square" rtlCol="0" anchor="ctr"/>
+          <a:lstStyle/>
+          <a:p>
+            <a:pPr indent="0" marL="0">
+              <a:lnSpc>
+                <a:spcPts val="1800"/>
+              </a:lnSpc>
+              <a:buNone/>
+            </a:pPr>
+            <a:r>
+              <a:rPr lang="en-US" sz="1250" dirty="0">
+                <a:solidFill>
+                  <a:srgbClr val="FFFFFF"/>
+                </a:solidFill>
+                <a:latin typeface="Arial" pitchFamily="34" charset="0"/>
+                <a:ea typeface="Arial" pitchFamily="34" charset="-122"/>
+                <a:cs typeface="Arial" pitchFamily="34" charset="-120"/>
+              </a:rPr>
+              <a:t>• Version Control: Hosted on GitHub with comprehensive commit logs.</a:t>
+            </a:r>
+            <a:endParaRPr lang="en-US" sz="1250" dirty="0"/>
+          </a:p>
+          <a:p>
+            <a:pPr indent="0" marL="0">
+              <a:lnSpc>
+                <a:spcPts val="1800"/>
+              </a:lnSpc>
+              <a:buNone/>
+            </a:pPr>
+            <a:endParaRPr lang="en-US" sz="1250" dirty="0"/>
+          </a:p>
+          <a:p>
+            <a:pPr indent="0" marL="0">
+              <a:lnSpc>
+                <a:spcPts val="1800"/>
+              </a:lnSpc>
+              <a:buNone/>
+            </a:pPr>
+            <a:r>
+              <a:rPr lang="en-US" sz="1250" dirty="0">
+                <a:solidFill>
+                  <a:srgbClr val="FFFFFF"/>
+                </a:solidFill>
+                <a:latin typeface="Arial" pitchFamily="34" charset="0"/>
+                <a:ea typeface="Arial" pitchFamily="34" charset="-122"/>
+                <a:cs typeface="Arial" pitchFamily="34" charset="-120"/>
+              </a:rPr>
+              <a:t>• Technology Highlights: Next.js 14 App Router, TypeScript, Tailwind CSS, and custom AI prompt pipelines.</a:t>
+            </a:r>
+            <a:endParaRPr lang="en-US" sz="1250" dirty="0"/>
+          </a:p>
+          <a:p>
+            <a:pPr indent="0" marL="0">
+              <a:lnSpc>
+                <a:spcPts val="1800"/>
+              </a:lnSpc>
+              <a:buNone/>
+            </a:pPr>
+            <a:endParaRPr lang="en-US" sz="1250" dirty="0"/>
+          </a:p>
+          <a:p>
+            <a:pPr indent="0" marL="0">
+              <a:lnSpc>
+                <a:spcPts val="1800"/>
+              </a:lnSpc>
+              <a:buNone/>
+            </a:pPr>
+            <a:r>
+              <a:rPr lang="en-US" sz="1250" dirty="0">
+                <a:solidFill>
+                  <a:srgbClr val="FFFFFF"/>
+                </a:solidFill>
+                <a:latin typeface="Arial" pitchFamily="34" charset="0"/>
+                <a:ea typeface="Arial" pitchFamily="34" charset="-122"/>
+                <a:cs typeface="Arial" pitchFamily="34" charset="-120"/>
+              </a:rPr>
+              <a:t>• Setup Guide: Comprehensive README.md file detailing local compilation commands and environment variables setup.</a:t>
+            </a:r>
+            <a:endParaRPr lang="en-US" sz="1250" dirty="0"/>
+          </a:p>
+          <a:p>
+            <a:pPr indent="0" marL="0">
+              <a:lnSpc>
+                <a:spcPts val="1800"/>
+              </a:lnSpc>
+              <a:buNone/>
+            </a:pPr>
+            <a:endParaRPr lang="en-US" sz="1250" dirty="0"/>
+          </a:p>
+          <a:p>
+            <a:pPr indent="0" marL="0">
+              <a:lnSpc>
+                <a:spcPts val="1800"/>
+              </a:lnSpc>
+              <a:buNone/>
+            </a:pPr>
+            <a:r>
+              <a:rPr lang="en-US" sz="1250" dirty="0">
+                <a:solidFill>
+                  <a:srgbClr val="FFFFFF"/>
+                </a:solidFill>
+                <a:latin typeface="Arial" pitchFamily="34" charset="0"/>
+                <a:ea typeface="Arial" pitchFamily="34" charset="-122"/>
+                <a:cs typeface="Arial" pitchFamily="34" charset="-120"/>
+              </a:rPr>
+              <a:t>• Modular Design: Clean file structures split by concerns (components, state context hooks, local engines, database adapters).</a:t>
+            </a:r>
+            <a:endParaRPr lang="en-US" sz="1250" dirty="0"/>
           </a:p>
         </p:txBody>
       </p:sp>

</xml_diff>

<commit_message>
docs: update live deployment url to vercel link in ppt and codebase
</commit_message>
<xml_diff>
--- a/Submission/EduTrack_Presentation_Fixed.pptx
+++ b/Submission/EduTrack_Presentation_Fixed.pptx
@@ -2174,7 +2174,7 @@
                   </a:extLst>
                 </a:hlinkClick>
               </a:rPr>
-              <a:t>https://edutrack.app</a:t>
+              <a:t>https://edutrack-delta-drab.vercel.app</a:t>
             </a:r>
             <a:endParaRPr lang="en-US" sz="1600" dirty="0"/>
           </a:p>
@@ -7684,7 +7684,7 @@
                   </a:extLst>
                 </a:hlinkClick>
               </a:rPr>
-              <a:t>Access Live Application: https://edutrack.app</a:t>
+              <a:t>Access Live Application: https://edutrack-delta-drab.vercel.app</a:t>
             </a:r>
             <a:endParaRPr lang="en-US" sz="1400" dirty="0"/>
           </a:p>
@@ -8676,7 +8676,7 @@
                   </a:extLst>
                 </a:hlinkClick>
               </a:rPr>
-              <a:t>https://edutrack.app</a:t>
+              <a:t>https://edutrack-delta-drab.vercel.app</a:t>
             </a:r>
             <a:endParaRPr lang="en-US" sz="2000" dirty="0"/>
           </a:p>

</xml_diff>